<commit_message>
scripts for SSM extraction
</commit_message>
<xml_diff>
--- a/intermodel_comparison/dens_profiles.pptx
+++ b/intermodel_comparison/dens_profiles.pptx
@@ -272,7 +272,7 @@
           <a:p>
             <a:fld id="{CF541E7A-D5C2-4AC6-B7D5-58B68EFAB35C}" type="datetimeFigureOut">
               <a:rPr lang="en-US" smtClean="0"/>
-              <a:t>9/9/2026</a:t>
+              <a:t>9/11/2026</a:t>
             </a:fld>
             <a:endParaRPr lang="en-US"/>
           </a:p>
@@ -470,7 +470,7 @@
           <a:p>
             <a:fld id="{CF541E7A-D5C2-4AC6-B7D5-58B68EFAB35C}" type="datetimeFigureOut">
               <a:rPr lang="en-US" smtClean="0"/>
-              <a:t>9/9/2026</a:t>
+              <a:t>9/11/2026</a:t>
             </a:fld>
             <a:endParaRPr lang="en-US"/>
           </a:p>
@@ -678,7 +678,7 @@
           <a:p>
             <a:fld id="{CF541E7A-D5C2-4AC6-B7D5-58B68EFAB35C}" type="datetimeFigureOut">
               <a:rPr lang="en-US" smtClean="0"/>
-              <a:t>9/9/2026</a:t>
+              <a:t>9/11/2026</a:t>
             </a:fld>
             <a:endParaRPr lang="en-US"/>
           </a:p>
@@ -876,7 +876,7 @@
           <a:p>
             <a:fld id="{CF541E7A-D5C2-4AC6-B7D5-58B68EFAB35C}" type="datetimeFigureOut">
               <a:rPr lang="en-US" smtClean="0"/>
-              <a:t>9/9/2026</a:t>
+              <a:t>9/11/2026</a:t>
             </a:fld>
             <a:endParaRPr lang="en-US"/>
           </a:p>
@@ -1151,7 +1151,7 @@
           <a:p>
             <a:fld id="{CF541E7A-D5C2-4AC6-B7D5-58B68EFAB35C}" type="datetimeFigureOut">
               <a:rPr lang="en-US" smtClean="0"/>
-              <a:t>9/9/2026</a:t>
+              <a:t>9/11/2026</a:t>
             </a:fld>
             <a:endParaRPr lang="en-US"/>
           </a:p>
@@ -1416,7 +1416,7 @@
           <a:p>
             <a:fld id="{CF541E7A-D5C2-4AC6-B7D5-58B68EFAB35C}" type="datetimeFigureOut">
               <a:rPr lang="en-US" smtClean="0"/>
-              <a:t>9/9/2026</a:t>
+              <a:t>9/11/2026</a:t>
             </a:fld>
             <a:endParaRPr lang="en-US"/>
           </a:p>
@@ -1828,7 +1828,7 @@
           <a:p>
             <a:fld id="{CF541E7A-D5C2-4AC6-B7D5-58B68EFAB35C}" type="datetimeFigureOut">
               <a:rPr lang="en-US" smtClean="0"/>
-              <a:t>9/9/2026</a:t>
+              <a:t>9/11/2026</a:t>
             </a:fld>
             <a:endParaRPr lang="en-US"/>
           </a:p>
@@ -1969,7 +1969,7 @@
           <a:p>
             <a:fld id="{CF541E7A-D5C2-4AC6-B7D5-58B68EFAB35C}" type="datetimeFigureOut">
               <a:rPr lang="en-US" smtClean="0"/>
-              <a:t>9/9/2026</a:t>
+              <a:t>9/11/2026</a:t>
             </a:fld>
             <a:endParaRPr lang="en-US"/>
           </a:p>
@@ -2082,7 +2082,7 @@
           <a:p>
             <a:fld id="{CF541E7A-D5C2-4AC6-B7D5-58B68EFAB35C}" type="datetimeFigureOut">
               <a:rPr lang="en-US" smtClean="0"/>
-              <a:t>9/9/2026</a:t>
+              <a:t>9/11/2026</a:t>
             </a:fld>
             <a:endParaRPr lang="en-US"/>
           </a:p>
@@ -2393,7 +2393,7 @@
           <a:p>
             <a:fld id="{CF541E7A-D5C2-4AC6-B7D5-58B68EFAB35C}" type="datetimeFigureOut">
               <a:rPr lang="en-US" smtClean="0"/>
-              <a:t>9/9/2026</a:t>
+              <a:t>9/11/2026</a:t>
             </a:fld>
             <a:endParaRPr lang="en-US"/>
           </a:p>
@@ -2681,7 +2681,7 @@
           <a:p>
             <a:fld id="{CF541E7A-D5C2-4AC6-B7D5-58B68EFAB35C}" type="datetimeFigureOut">
               <a:rPr lang="en-US" smtClean="0"/>
-              <a:t>9/9/2026</a:t>
+              <a:t>9/11/2026</a:t>
             </a:fld>
             <a:endParaRPr lang="en-US"/>
           </a:p>
@@ -2922,7 +2922,7 @@
           <a:p>
             <a:fld id="{CF541E7A-D5C2-4AC6-B7D5-58B68EFAB35C}" type="datetimeFigureOut">
               <a:rPr lang="en-US" smtClean="0"/>
-              <a:t>9/9/2026</a:t>
+              <a:t>9/11/2026</a:t>
             </a:fld>
             <a:endParaRPr lang="en-US"/>
           </a:p>
@@ -4465,7 +4465,7 @@
         </p:blipFill>
         <p:spPr>
           <a:xfrm>
-            <a:off x="4051458" y="1654689"/>
+            <a:off x="629058" y="2465644"/>
             <a:ext cx="3966481" cy="1926711"/>
           </a:xfrm>
           <a:prstGeom prst="rect">
@@ -4495,7 +4495,7 @@
         </p:blipFill>
         <p:spPr>
           <a:xfrm>
-            <a:off x="63273" y="1654689"/>
+            <a:off x="629058" y="538933"/>
             <a:ext cx="3966482" cy="1926711"/>
           </a:xfrm>
           <a:prstGeom prst="rect">
@@ -4525,7 +4525,7 @@
         </p:blipFill>
         <p:spPr>
           <a:xfrm>
-            <a:off x="8017939" y="1654689"/>
+            <a:off x="528230" y="4392355"/>
             <a:ext cx="4067309" cy="1975688"/>
           </a:xfrm>
           <a:prstGeom prst="rect">
@@ -4533,6 +4533,170 @@
           </a:prstGeom>
         </p:spPr>
       </p:pic>
+      <p:pic>
+        <p:nvPicPr>
+          <p:cNvPr id="15" name="Picture 14">
+            <a:extLst>
+              <a:ext uri="{FF2B5EF4-FFF2-40B4-BE49-F238E27FC236}">
+                <a16:creationId xmlns:a16="http://schemas.microsoft.com/office/drawing/2014/main" id="{5DB2BFE7-0757-80ED-04A0-F767AC9F757E}"/>
+              </a:ext>
+            </a:extLst>
+          </p:cNvPr>
+          <p:cNvPicPr>
+            <a:picLocks noChangeAspect="1"/>
+          </p:cNvPicPr>
+          <p:nvPr/>
+        </p:nvPicPr>
+        <p:blipFill>
+          <a:blip r:embed="rId5"/>
+          <a:srcRect l="9602" t="5170" r="33814" b="10008"/>
+          <a:stretch>
+            <a:fillRect/>
+          </a:stretch>
+        </p:blipFill>
+        <p:spPr>
+          <a:xfrm>
+            <a:off x="4763259" y="1047145"/>
+            <a:ext cx="2665482" cy="4497009"/>
+          </a:xfrm>
+          <a:prstGeom prst="rect">
+            <a:avLst/>
+          </a:prstGeom>
+        </p:spPr>
+      </p:pic>
+      <p:cxnSp>
+        <p:nvCxnSpPr>
+          <p:cNvPr id="17" name="Straight Arrow Connector 16">
+            <a:extLst>
+              <a:ext uri="{FF2B5EF4-FFF2-40B4-BE49-F238E27FC236}">
+                <a16:creationId xmlns:a16="http://schemas.microsoft.com/office/drawing/2014/main" id="{6263D617-F083-2AA9-3C37-4EC10BC79250}"/>
+              </a:ext>
+            </a:extLst>
+          </p:cNvPr>
+          <p:cNvCxnSpPr>
+            <a:cxnSpLocks/>
+            <a:stCxn id="9" idx="3"/>
+          </p:cNvCxnSpPr>
+          <p:nvPr/>
+        </p:nvCxnSpPr>
+        <p:spPr>
+          <a:xfrm flipV="1">
+            <a:off x="4595540" y="1249876"/>
+            <a:ext cx="1843360" cy="252413"/>
+          </a:xfrm>
+          <a:prstGeom prst="straightConnector1">
+            <a:avLst/>
+          </a:prstGeom>
+          <a:ln w="38100">
+            <a:solidFill>
+              <a:schemeClr val="tx1"/>
+            </a:solidFill>
+            <a:tailEnd type="triangle"/>
+          </a:ln>
+        </p:spPr>
+        <p:style>
+          <a:lnRef idx="2">
+            <a:schemeClr val="accent1"/>
+          </a:lnRef>
+          <a:fillRef idx="0">
+            <a:schemeClr val="accent1"/>
+          </a:fillRef>
+          <a:effectRef idx="1">
+            <a:schemeClr val="accent1"/>
+          </a:effectRef>
+          <a:fontRef idx="minor">
+            <a:schemeClr val="tx1"/>
+          </a:fontRef>
+        </p:style>
+      </p:cxnSp>
+      <p:cxnSp>
+        <p:nvCxnSpPr>
+          <p:cNvPr id="21" name="Straight Arrow Connector 20">
+            <a:extLst>
+              <a:ext uri="{FF2B5EF4-FFF2-40B4-BE49-F238E27FC236}">
+                <a16:creationId xmlns:a16="http://schemas.microsoft.com/office/drawing/2014/main" id="{8A0BA522-2667-CAE9-BCF2-6666DA0A3C9B}"/>
+              </a:ext>
+            </a:extLst>
+          </p:cNvPr>
+          <p:cNvCxnSpPr>
+            <a:cxnSpLocks/>
+          </p:cNvCxnSpPr>
+          <p:nvPr/>
+        </p:nvCxnSpPr>
+        <p:spPr>
+          <a:xfrm flipV="1">
+            <a:off x="4595540" y="1852821"/>
+            <a:ext cx="1843360" cy="1474460"/>
+          </a:xfrm>
+          <a:prstGeom prst="straightConnector1">
+            <a:avLst/>
+          </a:prstGeom>
+          <a:ln w="38100">
+            <a:solidFill>
+              <a:schemeClr val="tx1"/>
+            </a:solidFill>
+            <a:tailEnd type="triangle"/>
+          </a:ln>
+        </p:spPr>
+        <p:style>
+          <a:lnRef idx="2">
+            <a:schemeClr val="accent1"/>
+          </a:lnRef>
+          <a:fillRef idx="0">
+            <a:schemeClr val="accent1"/>
+          </a:fillRef>
+          <a:effectRef idx="1">
+            <a:schemeClr val="accent1"/>
+          </a:effectRef>
+          <a:fontRef idx="minor">
+            <a:schemeClr val="tx1"/>
+          </a:fontRef>
+        </p:style>
+      </p:cxnSp>
+      <p:cxnSp>
+        <p:nvCxnSpPr>
+          <p:cNvPr id="23" name="Straight Arrow Connector 22">
+            <a:extLst>
+              <a:ext uri="{FF2B5EF4-FFF2-40B4-BE49-F238E27FC236}">
+                <a16:creationId xmlns:a16="http://schemas.microsoft.com/office/drawing/2014/main" id="{A6786B06-3260-4D52-12AE-F57CE9AF71AD}"/>
+              </a:ext>
+            </a:extLst>
+          </p:cNvPr>
+          <p:cNvCxnSpPr>
+            <a:cxnSpLocks/>
+          </p:cNvCxnSpPr>
+          <p:nvPr/>
+        </p:nvCxnSpPr>
+        <p:spPr>
+          <a:xfrm flipV="1">
+            <a:off x="4595540" y="2213232"/>
+            <a:ext cx="2329135" cy="3087048"/>
+          </a:xfrm>
+          <a:prstGeom prst="straightConnector1">
+            <a:avLst/>
+          </a:prstGeom>
+          <a:ln w="38100">
+            <a:solidFill>
+              <a:schemeClr val="tx1"/>
+            </a:solidFill>
+            <a:tailEnd type="triangle"/>
+          </a:ln>
+        </p:spPr>
+        <p:style>
+          <a:lnRef idx="2">
+            <a:schemeClr val="accent1"/>
+          </a:lnRef>
+          <a:fillRef idx="0">
+            <a:schemeClr val="accent1"/>
+          </a:fillRef>
+          <a:effectRef idx="1">
+            <a:schemeClr val="accent1"/>
+          </a:effectRef>
+          <a:fontRef idx="minor">
+            <a:schemeClr val="tx1"/>
+          </a:fontRef>
+        </p:style>
+      </p:cxnSp>
     </p:spTree>
     <p:extLst>
       <p:ext uri="{BB962C8B-B14F-4D97-AF65-F5344CB8AC3E}">

</xml_diff>